<commit_message>
chore(ppt) - update of presentation powerpoint
</commit_message>
<xml_diff>
--- a/presentation/rtc_chat_project.pptx
+++ b/presentation/rtc_chat_project.pptx
@@ -661,7 +661,7 @@
                 <a:uFillTx/>
                 <a:latin typeface="Arial"/>
               </a:rPr>
-              <a:t>RTC Chat Project</a:t>
+              <a:t>RTC Chat Project – Who we are ?</a:t>
             </a:r>
             <a:endParaRPr lang="en-GB" sz="1800" b="0" u="none" strike="noStrike">
               <a:solidFill>
@@ -723,6 +723,70 @@
                 <a:latin typeface="Arial"/>
               </a:rPr>
               <a:t>Presentation of team</a:t>
+            </a:r>
+            <a:endParaRPr lang="en-GB" sz="1800" b="0" u="none" strike="noStrike">
+              <a:solidFill>
+                <a:srgbClr val="000000"/>
+              </a:solidFill>
+              <a:effectLst/>
+              <a:uFillTx/>
+              <a:latin typeface="Arial"/>
+            </a:endParaRPr>
+          </a:p>
+          <a:p>
+            <a:pPr marL="432000" indent="-324000">
+              <a:spcBef>
+                <a:spcPts val="1417"/>
+              </a:spcBef>
+              <a:buClr>
+                <a:srgbClr val="000000"/>
+              </a:buClr>
+              <a:buSzPct val="45000"/>
+              <a:buFont typeface="Wingdings" charset="2"/>
+              <a:buChar char=""/>
+            </a:pPr>
+            <a:r>
+              <a:rPr lang="en-GB" sz="1800" b="0" u="none" strike="noStrike">
+                <a:solidFill>
+                  <a:srgbClr val="000000"/>
+                </a:solidFill>
+                <a:effectLst/>
+                <a:uFillTx/>
+                <a:latin typeface="Arial"/>
+              </a:rPr>
+              <a:t>Why did we group together ?</a:t>
+            </a:r>
+            <a:endParaRPr lang="en-GB" sz="1800" b="0" u="none" strike="noStrike">
+              <a:solidFill>
+                <a:srgbClr val="000000"/>
+              </a:solidFill>
+              <a:effectLst/>
+              <a:uFillTx/>
+              <a:latin typeface="Arial"/>
+            </a:endParaRPr>
+          </a:p>
+          <a:p>
+            <a:pPr marL="432000" indent="-324000">
+              <a:spcBef>
+                <a:spcPts val="1417"/>
+              </a:spcBef>
+              <a:buClr>
+                <a:srgbClr val="000000"/>
+              </a:buClr>
+              <a:buSzPct val="45000"/>
+              <a:buFont typeface="Wingdings" charset="2"/>
+              <a:buChar char=""/>
+            </a:pPr>
+            <a:r>
+              <a:rPr lang="en-GB" sz="1800" b="0" u="none" strike="noStrike">
+                <a:solidFill>
+                  <a:srgbClr val="000000"/>
+                </a:solidFill>
+                <a:effectLst/>
+                <a:uFillTx/>
+                <a:latin typeface="Arial"/>
+              </a:rPr>
+              <a:t>What did we want to perform ?</a:t>
             </a:r>
             <a:endParaRPr lang="en-GB" sz="1800" b="0" u="none" strike="noStrike">
               <a:solidFill>

</xml_diff>